<commit_message>
Add entrepreneurship assignments, project files, and update Chapter 4 slides
</commit_message>
<xml_diff>
--- a/Slides/Chapter 4 Writing a Business Plan-.pptx
+++ b/Slides/Chapter 4 Writing a Business Plan-.pptx
@@ -7098,7 +7098,7 @@
             <a:fld id="{E59E2696-0F63-4036-8EB1-C1C5CD76B376}" type="datetimeFigureOut">
               <a:rPr lang="en-US" smtClean="0"/>
               <a:pPr/>
-              <a:t>3/10/2026</a:t>
+              <a:t>3/5/2023</a:t>
             </a:fld>
             <a:endParaRPr lang="en-US"/>
           </a:p>
@@ -7685,7 +7685,7 @@
                 </a:solidFill>
               </a:rPr>
               <a:pPr/>
-              <a:t>3/10/2026</a:t>
+              <a:t>3/5/2023</a:t>
             </a:fld>
             <a:endParaRPr lang="en-US">
               <a:solidFill>
@@ -8131,7 +8131,7 @@
                 </a:solidFill>
               </a:rPr>
               <a:pPr/>
-              <a:t>3/10/2026</a:t>
+              <a:t>3/5/2023</a:t>
             </a:fld>
             <a:endParaRPr lang="en-US">
               <a:solidFill>
@@ -8275,7 +8275,7 @@
                 </a:solidFill>
               </a:rPr>
               <a:pPr/>
-              <a:t>3/10/2026</a:t>
+              <a:t>3/5/2023</a:t>
             </a:fld>
             <a:endParaRPr lang="en-US">
               <a:solidFill>
@@ -8397,7 +8397,7 @@
                 </a:solidFill>
               </a:rPr>
               <a:pPr/>
-              <a:t>3/10/2026</a:t>
+              <a:t>3/5/2023</a:t>
             </a:fld>
             <a:endParaRPr lang="en-US">
               <a:solidFill>
@@ -8699,7 +8699,7 @@
                 </a:solidFill>
               </a:rPr>
               <a:pPr/>
-              <a:t>3/10/2026</a:t>
+              <a:t>3/5/2023</a:t>
             </a:fld>
             <a:endParaRPr lang="en-US">
               <a:solidFill>
@@ -8978,7 +8978,7 @@
                 </a:solidFill>
               </a:rPr>
               <a:pPr/>
-              <a:t>3/10/2026</a:t>
+              <a:t>3/5/2023</a:t>
             </a:fld>
             <a:endParaRPr lang="en-US">
               <a:solidFill>
@@ -9173,7 +9173,7 @@
                 </a:solidFill>
               </a:rPr>
               <a:pPr/>
-              <a:t>3/10/2026</a:t>
+              <a:t>3/5/2023</a:t>
             </a:fld>
             <a:endParaRPr lang="en-US">
               <a:solidFill>
@@ -9378,7 +9378,7 @@
                 </a:solidFill>
               </a:rPr>
               <a:pPr/>
-              <a:t>3/10/2026</a:t>
+              <a:t>3/5/2023</a:t>
             </a:fld>
             <a:endParaRPr lang="en-US">
               <a:solidFill>
@@ -10306,7 +10306,7 @@
             <a:fld id="{46B94673-4C73-4DD6-BF6D-B4E6209BB6BB}" type="datetimeFigureOut">
               <a:rPr lang="en-US" smtClean="0"/>
               <a:pPr/>
-              <a:t>3/10/2026</a:t>
+              <a:t>3/5/2023</a:t>
             </a:fld>
             <a:endParaRPr lang="en-US"/>
           </a:p>
@@ -10557,7 +10557,7 @@
                 </a:solidFill>
               </a:rPr>
               <a:pPr/>
-              <a:t>3/10/2026</a:t>
+              <a:t>3/5/2023</a:t>
             </a:fld>
             <a:endParaRPr lang="en-US">
               <a:solidFill>
@@ -10752,7 +10752,7 @@
                 </a:solidFill>
               </a:rPr>
               <a:pPr/>
-              <a:t>3/10/2026</a:t>
+              <a:t>3/5/2023</a:t>
             </a:fld>
             <a:endParaRPr lang="en-US">
               <a:solidFill>
@@ -11024,7 +11024,7 @@
                 </a:solidFill>
               </a:rPr>
               <a:pPr/>
-              <a:t>3/10/2026</a:t>
+              <a:t>3/5/2023</a:t>
             </a:fld>
             <a:endParaRPr lang="en-US">
               <a:solidFill>
@@ -11746,7 +11746,7 @@
                 </a:solidFill>
               </a:rPr>
               <a:pPr defTabSz="914400"/>
-              <a:t>3/10/2026</a:t>
+              <a:t>3/5/2023</a:t>
             </a:fld>
             <a:endParaRPr lang="en-US">
               <a:solidFill>
@@ -12906,10 +12906,9 @@
               <a:defRPr/>
             </a:pPr>
             <a:r>
-              <a:rPr lang="en-US" sz="2400"/>
-              <a:t>Poor Marketing</a:t>
-            </a:r>
-            <a:endParaRPr lang="en-US" sz="2400" dirty="0"/>
+              <a:rPr lang="en-US" sz="2400" dirty="0"/>
+              <a:t>Poor logistics &amp; Cost Management</a:t>
+            </a:r>
           </a:p>
           <a:p>
             <a:pPr marL="463550" lvl="1" indent="-463550" algn="just">

</xml_diff>